<commit_message>
Keep native shell builds and imported speaker notes consistent
</commit_message>
<xml_diff>
--- a/tests/fixtures/rebrand/recreate.pptx
+++ b/tests/fixtures/rebrand/recreate.pptx
@@ -343,9 +343,8 @@
               <a:rPr lang="en-US" dirty="0"/>
               <a:t>Thank the crews by name.</a:t>
             </a:r>
-            <a:br>
-              <a:rPr lang="en-US" dirty="0"/>
-            </a:br>
+          </a:p>
+          <a:p>
             <a:r>
               <a:rPr lang="en-US" dirty="0"/>
               <a:t>Point to the shared tide table.</a:t>

</xml_diff>